<commit_message>
Modularize dashboard, add Express+SQLite backend, fix table column widths
Split monolithic dashboard.jsx (1294 lines) into modular structure:
- src/App.jsx (root state + routing), src/App.css (extracted CSS)
- src/components/ (9 components: tabs, modals, shared UI)
- src/data/ (tools.js, logs.js, rankings.js)
- server/index.js (Express + better-sqlite3 API)
- scripts/generate-logs.js (generates 482 real .txt log files)
- Frontend connected to backend API via Vite proxy
- Added table-layout:fixed to all tables and fixed flex column widths
  to prevent layout shifts when filtering/sorting

Co-Authored-By: Claude Opus 4.6 <noreply@anthropic.com>
</commit_message>
<xml_diff>
--- a/presentation.pptx
+++ b/presentation.pptx
@@ -5870,7 +5870,7 @@
         </p:nvSpPr>
         <p:spPr>
           <a:xfrm>
-            <a:off x="731520" y="1371600"/>
+            <a:off x="731520" y="1679712"/>
             <a:ext cx="3383280" cy="4114800"/>
           </a:xfrm>
           <a:prstGeom prst="roundRect">
@@ -5916,7 +5916,7 @@
         </p:nvSpPr>
         <p:spPr>
           <a:xfrm>
-            <a:off x="749808" y="1371600"/>
+            <a:off x="749808" y="1321903"/>
             <a:ext cx="3346704" cy="36576"/>
           </a:xfrm>
           <a:prstGeom prst="rect">
@@ -5960,7 +5960,7 @@
         </p:nvSpPr>
         <p:spPr>
           <a:xfrm>
-            <a:off x="1005840" y="1645920"/>
+            <a:off x="1005840" y="1954032"/>
             <a:ext cx="2834640" cy="457200"/>
           </a:xfrm>
           <a:prstGeom prst="rect">
@@ -5995,7 +5995,7 @@
         </p:nvSpPr>
         <p:spPr>
           <a:xfrm>
-            <a:off x="1005840" y="2286000"/>
+            <a:off x="1005840" y="2594112"/>
             <a:ext cx="2834640" cy="365760"/>
           </a:xfrm>
           <a:prstGeom prst="rect">
@@ -6030,7 +6030,7 @@
         </p:nvSpPr>
         <p:spPr>
           <a:xfrm>
-            <a:off x="1005840" y="2834640"/>
+            <a:off x="1005840" y="3142752"/>
             <a:ext cx="2834640" cy="1097280"/>
           </a:xfrm>
           <a:prstGeom prst="rect">
@@ -6069,7 +6069,7 @@
         </p:nvSpPr>
         <p:spPr>
           <a:xfrm>
-            <a:off x="1005840" y="4297680"/>
+            <a:off x="1005840" y="4605792"/>
             <a:ext cx="2834640" cy="731520"/>
           </a:xfrm>
           <a:prstGeom prst="roundRect">
@@ -6115,7 +6115,7 @@
         </p:nvSpPr>
         <p:spPr>
           <a:xfrm>
-            <a:off x="1005840" y="4434840"/>
+            <a:off x="1005840" y="4742952"/>
             <a:ext cx="2834640" cy="292388"/>
           </a:xfrm>
           <a:prstGeom prst="rect">
@@ -6164,7 +6164,7 @@
         </p:nvSpPr>
         <p:spPr>
           <a:xfrm>
-            <a:off x="4389120" y="1371600"/>
+            <a:off x="4389120" y="1679712"/>
             <a:ext cx="3383280" cy="4114800"/>
           </a:xfrm>
           <a:prstGeom prst="roundRect">
@@ -6210,7 +6210,7 @@
         </p:nvSpPr>
         <p:spPr>
           <a:xfrm>
-            <a:off x="4407408" y="1371600"/>
+            <a:off x="4407408" y="1321903"/>
             <a:ext cx="3346704" cy="36576"/>
           </a:xfrm>
           <a:prstGeom prst="rect">
@@ -6254,7 +6254,7 @@
         </p:nvSpPr>
         <p:spPr>
           <a:xfrm>
-            <a:off x="4663440" y="1645920"/>
+            <a:off x="4663440" y="1954032"/>
             <a:ext cx="2834640" cy="457200"/>
           </a:xfrm>
           <a:prstGeom prst="rect">
@@ -6289,7 +6289,7 @@
         </p:nvSpPr>
         <p:spPr>
           <a:xfrm>
-            <a:off x="4663440" y="2286000"/>
+            <a:off x="4663440" y="2594112"/>
             <a:ext cx="2834640" cy="365760"/>
           </a:xfrm>
           <a:prstGeom prst="rect">
@@ -6324,7 +6324,7 @@
         </p:nvSpPr>
         <p:spPr>
           <a:xfrm>
-            <a:off x="4663440" y="2834640"/>
+            <a:off x="4663440" y="3142752"/>
             <a:ext cx="2834640" cy="1097280"/>
           </a:xfrm>
           <a:prstGeom prst="rect">
@@ -6363,7 +6363,7 @@
         </p:nvSpPr>
         <p:spPr>
           <a:xfrm>
-            <a:off x="4663440" y="4297680"/>
+            <a:off x="4663440" y="4605792"/>
             <a:ext cx="2834640" cy="731520"/>
           </a:xfrm>
           <a:prstGeom prst="roundRect">
@@ -6409,7 +6409,7 @@
         </p:nvSpPr>
         <p:spPr>
           <a:xfrm>
-            <a:off x="4663439" y="4434840"/>
+            <a:off x="4663439" y="4742952"/>
             <a:ext cx="2834639" cy="292388"/>
           </a:xfrm>
           <a:prstGeom prst="rect">
@@ -6458,7 +6458,7 @@
         </p:nvSpPr>
         <p:spPr>
           <a:xfrm>
-            <a:off x="8046720" y="1371600"/>
+            <a:off x="8046720" y="1679712"/>
             <a:ext cx="3383280" cy="4114800"/>
           </a:xfrm>
           <a:prstGeom prst="roundRect">
@@ -6504,7 +6504,7 @@
         </p:nvSpPr>
         <p:spPr>
           <a:xfrm>
-            <a:off x="8065008" y="1371600"/>
+            <a:off x="8065008" y="1321903"/>
             <a:ext cx="3346704" cy="36576"/>
           </a:xfrm>
           <a:prstGeom prst="rect">
@@ -6548,7 +6548,7 @@
         </p:nvSpPr>
         <p:spPr>
           <a:xfrm>
-            <a:off x="8321040" y="1645920"/>
+            <a:off x="8321040" y="1954032"/>
             <a:ext cx="2834640" cy="457200"/>
           </a:xfrm>
           <a:prstGeom prst="rect">
@@ -6583,7 +6583,7 @@
         </p:nvSpPr>
         <p:spPr>
           <a:xfrm>
-            <a:off x="8321040" y="2286000"/>
+            <a:off x="8321040" y="2594112"/>
             <a:ext cx="2834640" cy="365760"/>
           </a:xfrm>
           <a:prstGeom prst="rect">
@@ -6618,7 +6618,7 @@
         </p:nvSpPr>
         <p:spPr>
           <a:xfrm>
-            <a:off x="8321040" y="2834640"/>
+            <a:off x="8321040" y="3142752"/>
             <a:ext cx="2834640" cy="1097280"/>
           </a:xfrm>
           <a:prstGeom prst="rect">
@@ -6657,7 +6657,7 @@
         </p:nvSpPr>
         <p:spPr>
           <a:xfrm>
-            <a:off x="8321040" y="4297680"/>
+            <a:off x="8321040" y="4605792"/>
             <a:ext cx="2834640" cy="731520"/>
           </a:xfrm>
           <a:prstGeom prst="roundRect">
@@ -6703,7 +6703,7 @@
         </p:nvSpPr>
         <p:spPr>
           <a:xfrm>
-            <a:off x="8321040" y="4434840"/>
+            <a:off x="8321040" y="4742952"/>
             <a:ext cx="2834640" cy="292388"/>
           </a:xfrm>
           <a:prstGeom prst="rect">
@@ -11602,7 +11602,22 @@
               </a:defRPr>
             </a:pPr>
             <a:r>
-              <a:t>驗證?</a:t>
+              <a:rPr dirty="0" err="1"/>
+              <a:t>驗證</a:t>
+            </a:r>
+            <a:endParaRPr lang="en-US" dirty="0"/>
+          </a:p>
+          <a:p>
+            <a:pPr algn="ctr">
+              <a:defRPr sz="1100" b="1">
+                <a:solidFill>
+                  <a:srgbClr val="F39C12"/>
+                </a:solidFill>
+              </a:defRPr>
+            </a:pPr>
+            <a:r>
+              <a:rPr dirty="0"/>
+              <a:t>?</a:t>
             </a:r>
           </a:p>
         </p:txBody>
@@ -12048,8 +12063,14 @@
               </a:defRPr>
             </a:pPr>
             <a:r>
-              <a:t>Log 資料生命週期管理</a:t>
-            </a:r>
+              <a:rPr dirty="0"/>
+              <a:t>Log </a:t>
+            </a:r>
+            <a:r>
+              <a:rPr dirty="0" err="1"/>
+              <a:t>資料生命週期管理</a:t>
+            </a:r>
+            <a:endParaRPr dirty="0"/>
           </a:p>
         </p:txBody>
       </p:sp>
@@ -14120,8 +14141,8 @@
         </p:nvSpPr>
         <p:spPr>
           <a:xfrm>
-            <a:off x="914400" y="2834640"/>
-            <a:ext cx="3017520" cy="1828800"/>
+            <a:off x="731520" y="2834640"/>
+            <a:ext cx="3364992" cy="1538883"/>
           </a:xfrm>
           <a:prstGeom prst="rect">
             <a:avLst/>
@@ -14142,20 +14163,172 @@
               </a:defRPr>
             </a:pPr>
             <a:r>
-              <a:t>前端 Dashboard 完成</a:t>
-            </a:r>
-            <a:br/>
-            <a:r>
+              <a:rPr dirty="0" err="1">
+                <a:ea typeface="微軟正黑體" panose="020B0604030504040204" pitchFamily="34" charset="-120"/>
+              </a:rPr>
+              <a:t>前端</a:t>
+            </a:r>
+            <a:r>
+              <a:rPr dirty="0">
+                <a:ea typeface="微軟正黑體" panose="020B0604030504040204" pitchFamily="34" charset="-120"/>
+              </a:rPr>
+              <a:t> Dashboard </a:t>
+            </a:r>
+            <a:r>
+              <a:rPr dirty="0" err="1">
+                <a:ea typeface="微軟正黑體" panose="020B0604030504040204" pitchFamily="34" charset="-120"/>
+              </a:rPr>
+              <a:t>完成</a:t>
+            </a:r>
+            <a:br>
+              <a:rPr dirty="0">
+                <a:ea typeface="微軟正黑體" panose="020B0604030504040204" pitchFamily="34" charset="-120"/>
+              </a:rPr>
+            </a:br>
+            <a:r>
+              <a:rPr dirty="0">
+                <a:ea typeface="微軟正黑體" panose="020B0604030504040204" pitchFamily="34" charset="-120"/>
+              </a:rPr>
               <a:t>Overview / Upload / Tool Status</a:t>
             </a:r>
-            <a:br/>
-            <a:r>
-              <a:t>三站 30 工具完整展示</a:t>
-            </a:r>
-            <a:br/>
-            <a:r>
-              <a:t>GitHub Pages 部署上線</a:t>
-            </a:r>
+            <a:br>
+              <a:rPr dirty="0">
+                <a:ea typeface="微軟正黑體" panose="020B0604030504040204" pitchFamily="34" charset="-120"/>
+              </a:rPr>
+            </a:br>
+            <a:r>
+              <a:rPr dirty="0" err="1">
+                <a:ea typeface="微軟正黑體" panose="020B0604030504040204" pitchFamily="34" charset="-120"/>
+              </a:rPr>
+              <a:t>三站</a:t>
+            </a:r>
+            <a:r>
+              <a:rPr dirty="0">
+                <a:ea typeface="微軟正黑體" panose="020B0604030504040204" pitchFamily="34" charset="-120"/>
+              </a:rPr>
+              <a:t> 30 </a:t>
+            </a:r>
+            <a:r>
+              <a:rPr dirty="0" err="1">
+                <a:ea typeface="微軟正黑體" panose="020B0604030504040204" pitchFamily="34" charset="-120"/>
+              </a:rPr>
+              <a:t>工具完整展示</a:t>
+            </a:r>
+            <a:br>
+              <a:rPr dirty="0">
+                <a:ea typeface="微軟正黑體" panose="020B0604030504040204" pitchFamily="34" charset="-120"/>
+              </a:rPr>
+            </a:br>
+            <a:r>
+              <a:rPr dirty="0">
+                <a:ea typeface="微軟正黑體" panose="020B0604030504040204" pitchFamily="34" charset="-120"/>
+              </a:rPr>
+              <a:t>GitHub Pages </a:t>
+            </a:r>
+            <a:r>
+              <a:rPr dirty="0" err="1">
+                <a:ea typeface="微軟正黑體" panose="020B0604030504040204" pitchFamily="34" charset="-120"/>
+              </a:rPr>
+              <a:t>部署上線</a:t>
+            </a:r>
+            <a:endParaRPr lang="en-US" dirty="0">
+              <a:ea typeface="微軟正黑體" panose="020B0604030504040204" pitchFamily="34" charset="-120"/>
+            </a:endParaRPr>
+          </a:p>
+          <a:p>
+            <a:pPr algn="ctr">
+              <a:defRPr sz="1400" b="0">
+                <a:solidFill>
+                  <a:srgbClr val="A8C8E8"/>
+                </a:solidFill>
+              </a:defRPr>
+            </a:pPr>
+            <a:r>
+              <a:rPr lang="zh-TW" altLang="en-US" dirty="0">
+                <a:ea typeface="微軟正黑體" panose="020B0604030504040204" pitchFamily="34" charset="-120"/>
+              </a:rPr>
+              <a:t>前端 </a:t>
+            </a:r>
+            <a:r>
+              <a:rPr lang="en-US" altLang="zh-TW" dirty="0">
+                <a:ea typeface="微軟正黑體" panose="020B0604030504040204" pitchFamily="34" charset="-120"/>
+              </a:rPr>
+              <a:t>Dashboard </a:t>
+            </a:r>
+            <a:r>
+              <a:rPr lang="en-US" altLang="zh-TW" sz="1400" dirty="0">
+                <a:solidFill>
+                  <a:srgbClr val="A8C8E8"/>
+                </a:solidFill>
+                <a:ea typeface="微軟正黑體" panose="020B0604030504040204" pitchFamily="34" charset="-120"/>
+              </a:rPr>
+              <a:t>Demo </a:t>
+            </a:r>
+            <a:r>
+              <a:rPr lang="zh-TW" altLang="en-US" sz="1400" dirty="0">
+                <a:solidFill>
+                  <a:srgbClr val="A8C8E8"/>
+                </a:solidFill>
+                <a:ea typeface="微軟正黑體" panose="020B0604030504040204" pitchFamily="34" charset="-120"/>
+              </a:rPr>
+              <a:t>網址</a:t>
+            </a:r>
+            <a:endParaRPr lang="en-US" sz="1400" dirty="0">
+              <a:solidFill>
+                <a:srgbClr val="A8C8E8"/>
+              </a:solidFill>
+              <a:ea typeface="微軟正黑體" panose="020B0604030504040204" pitchFamily="34" charset="-120"/>
+            </a:endParaRPr>
+          </a:p>
+          <a:p>
+            <a:pPr algn="ctr">
+              <a:defRPr sz="1400" b="0">
+                <a:solidFill>
+                  <a:srgbClr val="A8C8E8"/>
+                </a:solidFill>
+              </a:defRPr>
+            </a:pPr>
+            <a:r>
+              <a:rPr lang="zh-TW" altLang="en-US" sz="1000" dirty="0">
+                <a:solidFill>
+                  <a:schemeClr val="tx1">
+                    <a:lumMod val="95000"/>
+                    <a:lumOff val="5000"/>
+                  </a:schemeClr>
+                </a:solidFill>
+                <a:highlight>
+                  <a:srgbClr val="FFFF00"/>
+                </a:highlight>
+                <a:ea typeface="微軟正黑體" panose="020B0604030504040204" pitchFamily="34" charset="-120"/>
+                <a:hlinkClick r:id="rId2"/>
+              </a:rPr>
+              <a:t>https://meichenh84.github.io/ToolTrack-Dashboard/</a:t>
+            </a:r>
+            <a:r>
+              <a:rPr lang="zh-TW" altLang="en-US" sz="1000" dirty="0">
+                <a:solidFill>
+                  <a:schemeClr val="tx1">
+                    <a:lumMod val="95000"/>
+                    <a:lumOff val="5000"/>
+                  </a:schemeClr>
+                </a:solidFill>
+                <a:highlight>
+                  <a:srgbClr val="FFFF00"/>
+                </a:highlight>
+                <a:ea typeface="微軟正黑體" panose="020B0604030504040204" pitchFamily="34" charset="-120"/>
+              </a:rPr>
+              <a:t>   </a:t>
+            </a:r>
+          </a:p>
+          <a:p>
+            <a:pPr algn="ctr">
+              <a:defRPr sz="1400" b="0">
+                <a:solidFill>
+                  <a:srgbClr val="A8C8E8"/>
+                </a:solidFill>
+              </a:defRPr>
+            </a:pPr>
+            <a:endParaRPr dirty="0"/>
           </a:p>
         </p:txBody>
       </p:sp>
@@ -14672,7 +14845,7 @@
         <p:spPr>
           <a:xfrm>
             <a:off x="731520" y="5394960"/>
-            <a:ext cx="10149840" cy="457200"/>
+            <a:ext cx="10149840" cy="276999"/>
           </a:xfrm>
           <a:prstGeom prst="rect">
             <a:avLst/>
@@ -14693,8 +14866,81 @@
               </a:defRPr>
             </a:pPr>
             <a:r>
-              <a:t>💬 需要討論：伺服器資源申請  |  資料庫選型確認  |  時程規劃  |  團隊分工</a:t>
-            </a:r>
+              <a:rPr dirty="0"/>
+              <a:t>💬 </a:t>
+            </a:r>
+            <a:r>
+              <a:rPr dirty="0" err="1"/>
+              <a:t>需要討論：伺服器資源申請</a:t>
+            </a:r>
+            <a:r>
+              <a:rPr dirty="0"/>
+              <a:t>  |  </a:t>
+            </a:r>
+            <a:r>
+              <a:rPr dirty="0" err="1"/>
+              <a:t>資料庫選型確認</a:t>
+            </a:r>
+            <a:r>
+              <a:rPr dirty="0"/>
+              <a:t>  </a:t>
+            </a:r>
+            <a:r>
+              <a:rPr sz="1200" dirty="0">
+                <a:solidFill>
+                  <a:srgbClr val="A8C8E8"/>
+                </a:solidFill>
+              </a:rPr>
+              <a:t>|  </a:t>
+            </a:r>
+            <a:r>
+              <a:rPr lang="zh-TW" altLang="en-US" sz="1200" dirty="0">
+                <a:solidFill>
+                  <a:srgbClr val="A8C8E8"/>
+                </a:solidFill>
+                <a:ea typeface="微軟正黑體" panose="020B0604030504040204" pitchFamily="34" charset="-120"/>
+              </a:rPr>
+              <a:t>實際</a:t>
+            </a:r>
+            <a:r>
+              <a:rPr lang="en-US" altLang="zh-TW" sz="1200" dirty="0">
+                <a:solidFill>
+                  <a:srgbClr val="A8C8E8"/>
+                </a:solidFill>
+                <a:ea typeface="微軟正黑體" panose="020B0604030504040204" pitchFamily="34" charset="-120"/>
+              </a:rPr>
+              <a:t>Log</a:t>
+            </a:r>
+            <a:r>
+              <a:rPr lang="zh-TW" altLang="en-US" sz="1200" dirty="0">
+                <a:solidFill>
+                  <a:srgbClr val="A8C8E8"/>
+                </a:solidFill>
+                <a:ea typeface="微軟正黑體" panose="020B0604030504040204" pitchFamily="34" charset="-120"/>
+              </a:rPr>
+              <a:t>資料生命週期管理  </a:t>
+            </a:r>
+            <a:r>
+              <a:rPr lang="en-US" altLang="zh-TW" sz="1200" dirty="0">
+                <a:solidFill>
+                  <a:srgbClr val="A8C8E8"/>
+                </a:solidFill>
+              </a:rPr>
+              <a:t>|  </a:t>
+            </a:r>
+            <a:r>
+              <a:rPr dirty="0" err="1"/>
+              <a:t>時程規劃</a:t>
+            </a:r>
+            <a:r>
+              <a:rPr dirty="0"/>
+              <a:t>  |  </a:t>
+            </a:r>
+            <a:r>
+              <a:rPr dirty="0" err="1"/>
+              <a:t>團隊分工</a:t>
+            </a:r>
+            <a:endParaRPr dirty="0"/>
           </a:p>
         </p:txBody>
       </p:sp>

</xml_diff>